<commit_message>
Sesion 1: tiempos de la agenda alineados con el guion (presentaciones/Taller_Practico_1.pptx)
</commit_message>
<xml_diff>
--- a/presentaciones/Taller_Practico_1.pptx
+++ b/presentaciones/Taller_Practico_1.pptx
@@ -10199,7 +10199,7 @@
                 <a:ea typeface="Arial" pitchFamily="34" charset="-122"/>
                 <a:cs typeface="Arial" pitchFamily="34" charset="-120"/>
               </a:rPr>
-              <a:t>Pasos 1-4 · cuenta de Groq, llave y Secrets de Colab  ·  15 min</a:t>
+              <a:t>Pasos 1-4 · cuenta de Groq, llave y Secrets de Colab  ·  13 min</a:t>
             </a:r>
             <a:endParaRPr lang="en-US" sz="1000" dirty="0"/>
           </a:p>
@@ -10724,7 +10724,7 @@
                 <a:ea typeface="Arial" pitchFamily="34" charset="-122"/>
                 <a:cs typeface="Arial" pitchFamily="34" charset="-120"/>
               </a:rPr>
-              <a:t>Pasos 8-11 · armarlo, ejecutarlo y leer la traza  ·  22 min</a:t>
+              <a:t>Pasos 8-11 · armarlo, ejecutarlo y leer la traza  ·  24 min</a:t>
             </a:r>
             <a:endParaRPr lang="en-US" sz="1000" dirty="0"/>
           </a:p>

</xml_diff>